<commit_message>
feat: add unified text image and table generation
</commit_message>
<xml_diff>
--- a/tests/fixtures/test-img.pptx
+++ b/tests/fixtures/test-img.pptx
@@ -4346,57 +4346,6 @@
           </a:p>
         </p:txBody>
       </p:sp>
-      <p:sp>
-        <p:nvSpPr>
-          <p:cNvPr id="7" name="文本 1">
-            <a:extLst>
-              <a:ext uri="{FF2B5EF4-FFF2-40B4-BE49-F238E27FC236}">
-                <a16:creationId xmlns:a16="http://schemas.microsoft.com/office/drawing/2014/main" id="{83852F8A-68E8-98C1-7119-2B8FBA8B6D88}"/>
-              </a:ext>
-            </a:extLst>
-          </p:cNvPr>
-          <p:cNvSpPr>
-            <a:spLocks noGrp="1"/>
-          </p:cNvSpPr>
-          <p:nvPr>
-            <p:ph idx="1"/>
-          </p:nvPr>
-        </p:nvSpPr>
-        <p:spPr>
-          <a:xfrm>
-            <a:off x="437412" y="829498"/>
-            <a:ext cx="4634028" cy="543686"/>
-          </a:xfrm>
-          <a:prstGeom prst="rect">
-            <a:avLst/>
-          </a:prstGeom>
-        </p:spPr>
-        <p:txBody>
-          <a:bodyPr vert="horz" lIns="91440" tIns="45720" rIns="91440" bIns="45720" rtlCol="0">
-            <a:normAutofit/>
-          </a:bodyPr>
-          <a:lstStyle/>
-          <a:p>
-            <a:pPr lvl="0">
-              <a:buFont typeface="Wingdings" pitchFamily="2" charset="2"/>
-              <a:buChar char="n"/>
-            </a:pPr>
-            <a:r>
-              <a:rPr lang="en-US" sz="2400" dirty="0" err="1"/>
-              <a:t>分类</a:t>
-            </a:r>
-            <a:r>
-              <a:rPr lang="zh-CN" altLang="en-US" sz="2400" dirty="0"/>
-              <a:t>：</a:t>
-            </a:r>
-            <a:r>
-              <a:rPr lang="en-US" altLang="zh-CN" sz="2400" dirty="0"/>
-              <a:t>{{title}}</a:t>
-            </a:r>
-            <a:endParaRPr lang="en-US" sz="2400" dirty="0"/>
-          </a:p>
-        </p:txBody>
-      </p:sp>
       <p:pic>
         <p:nvPicPr>
           <p:cNvPr id="2" name="&lt;foreach item=imgs&gt;&lt;/foreach&gt;">
@@ -4514,7 +4463,7 @@
       </p:sp>
       <p:sp>
         <p:nvSpPr>
-          <p:cNvPr id="7" name="&lt;foreach item=tables block=reasonTable&gt;{{title}}&lt;/foreach&gt;">
+          <p:cNvPr id="7" name="&lt;foreach item=imageGroups block=equipment&gt;{{title}}&lt;/foreach&gt;">
             <a:extLst>
               <a:ext uri="{FF2B5EF4-FFF2-40B4-BE49-F238E27FC236}">
                 <a16:creationId xmlns:a16="http://schemas.microsoft.com/office/drawing/2014/main" id="{83852F8A-68E8-98C1-7119-2B8FBA8B6D88}"/>
@@ -4565,7 +4514,7 @@
       </p:sp>
       <p:pic>
         <p:nvPicPr>
-          <p:cNvPr id="2" name="图片 1">
+          <p:cNvPr id="2" name="&lt;foreach item=imageGroups block=equipment&gt;{{imagePath}}&lt;/foreach&gt;(x,y)">
             <a:extLst>
               <a:ext uri="{FF2B5EF4-FFF2-40B4-BE49-F238E27FC236}">
                 <a16:creationId xmlns:a16="http://schemas.microsoft.com/office/drawing/2014/main" id="{4CED8FE8-A5B8-00DD-F50F-F110FBA90071}"/>

</xml_diff>